<commit_message>
Future Scope: add the AI voice assistant
Stock tracking and its low-stock alert were two cards for what is really one
feature, so they now share a card. That frees a slot without dropping anything.

The freed slot plus the old "Voice & Vernacular Input" card become two AI cards:

- AI Voice Assistant - speech recognition and a language model let elders
  confirm doses by speaking in Hindi, Marathi or Gujarati, with the app replying
  in their language
- Conversational Insights - guardians ask questions of the care data and receive
  spoken adherence summaries

Kept deliberately short: enough to make the point in a viva without committing
to an architecture on a slide.

Co-Authored-By: Claude Opus 5 (1M context) <noreply@anthropic.com>
</commit_message>
<xml_diff>
--- a/ppt/CareCompanion-IE1-KJSSE.pptx
+++ b/ppt/CareCompanion-IE1-KJSSE.pptx
@@ -26456,7 +26456,7 @@
           <a:p>
             <a:pPr algn="ctr"/>
             <a:r>
-              <a:rPr sz="1666" b="1">
+              <a:rPr sz="1533" b="1">
                 <a:solidFill>
                   <a:srgbClr val="9B1C2E"/>
                 </a:solidFill>
@@ -26468,13 +26468,13 @@
           <a:p>
             <a:pPr algn="ctr"/>
             <a:r>
-              <a:rPr sz="1466" b="0">
+              <a:rPr sz="1333" b="0">
                 <a:solidFill>
                   <a:srgbClr val="101010"/>
                 </a:solidFill>
                 <a:latin typeface="Calibri"/>
               </a:rPr>
-              <a:t>Track quantity in hand; stock falls as doses are taken</a:t>
+              <a:t>Track quantity in hand; stock falls as doses are taken and the guardian is alerted before a medicine runs out</a:t>
             </a:r>
           </a:p>
         </p:txBody>
@@ -26578,25 +26578,25 @@
           <a:p>
             <a:pPr algn="ctr"/>
             <a:r>
-              <a:rPr sz="1666" b="1">
+              <a:rPr sz="1533" b="1">
                 <a:solidFill>
                   <a:srgbClr val="9B1C2E"/>
                 </a:solidFill>
                 <a:latin typeface="Georgia"/>
               </a:rPr>
-              <a:t>Low-Stock Alerts</a:t>
+              <a:t>AI Voice Assistant</a:t>
             </a:r>
           </a:p>
           <a:p>
             <a:pPr algn="ctr"/>
             <a:r>
-              <a:rPr sz="1466" b="0">
+              <a:rPr sz="1333" b="0">
                 <a:solidFill>
                   <a:srgbClr val="101010"/>
                 </a:solidFill>
                 <a:latin typeface="Calibri"/>
               </a:rPr>
-              <a:t>Guardian notified before a medicine runs out, to restock in time</a:t>
+              <a:t>Speech recognition and a language model let elders confirm doses by speaking in Hindi, Marathi or Gujarati, and the app replies in their language</a:t>
             </a:r>
           </a:p>
         </p:txBody>
@@ -26700,25 +26700,25 @@
           <a:p>
             <a:pPr algn="ctr"/>
             <a:r>
-              <a:rPr sz="1666" b="1">
+              <a:rPr sz="1533" b="1">
                 <a:solidFill>
                   <a:srgbClr val="9B1C2E"/>
                 </a:solidFill>
                 <a:latin typeface="Georgia"/>
               </a:rPr>
-              <a:t>iOS Application</a:t>
+              <a:t>Conversational Insights</a:t>
             </a:r>
           </a:p>
           <a:p>
             <a:pPr algn="ctr"/>
             <a:r>
-              <a:rPr sz="1466" b="0">
+              <a:rPr sz="1333" b="0">
                 <a:solidFill>
                   <a:srgbClr val="101010"/>
                 </a:solidFill>
                 <a:latin typeface="Calibri"/>
               </a:rPr>
-              <a:t>Extend CareCompanion to iPhone users</a:t>
+              <a:t>Guardians ask questions of the care data and receive spoken adherence summaries</a:t>
             </a:r>
           </a:p>
         </p:txBody>
@@ -26822,25 +26822,25 @@
           <a:p>
             <a:pPr algn="ctr"/>
             <a:r>
-              <a:rPr sz="1666" b="1">
+              <a:rPr sz="1533" b="1">
                 <a:solidFill>
                   <a:srgbClr val="9B1C2E"/>
                 </a:solidFill>
                 <a:latin typeface="Georgia"/>
               </a:rPr>
-              <a:t>Google Play Release</a:t>
+              <a:t>iOS Application</a:t>
             </a:r>
           </a:p>
           <a:p>
             <a:pPr algn="ctr"/>
             <a:r>
-              <a:rPr sz="1466" b="0">
+              <a:rPr sz="1333" b="0">
                 <a:solidFill>
                   <a:srgbClr val="101010"/>
                 </a:solidFill>
                 <a:latin typeface="Calibri"/>
               </a:rPr>
-              <a:t>Publish for public distribution and real-world use</a:t>
+              <a:t>Extend CareCompanion to iPhone users</a:t>
             </a:r>
           </a:p>
         </p:txBody>
@@ -26944,25 +26944,25 @@
           <a:p>
             <a:pPr algn="ctr"/>
             <a:r>
-              <a:rPr sz="1666" b="1">
+              <a:rPr sz="1533" b="1">
                 <a:solidFill>
                   <a:srgbClr val="9B1C2E"/>
                 </a:solidFill>
                 <a:latin typeface="Georgia"/>
               </a:rPr>
-              <a:t>User Study</a:t>
+              <a:t>Google Play Release</a:t>
             </a:r>
           </a:p>
           <a:p>
             <a:pPr algn="ctr"/>
             <a:r>
-              <a:rPr sz="1466" b="0">
+              <a:rPr sz="1333" b="0">
                 <a:solidFill>
                   <a:srgbClr val="101010"/>
                 </a:solidFill>
                 <a:latin typeface="Calibri"/>
               </a:rPr>
-              <a:t>Evaluate with elderly participants and their caregivers</a:t>
+              <a:t>Publish for public distribution and real-world use</a:t>
             </a:r>
           </a:p>
         </p:txBody>
@@ -27066,25 +27066,25 @@
           <a:p>
             <a:pPr algn="ctr"/>
             <a:r>
-              <a:rPr sz="1666" b="1">
+              <a:rPr sz="1533" b="1">
                 <a:solidFill>
                   <a:srgbClr val="9B1C2E"/>
                 </a:solidFill>
                 <a:latin typeface="Georgia"/>
               </a:rPr>
-              <a:t>Voice &amp; Vernacular Input</a:t>
+              <a:t>User Study</a:t>
             </a:r>
           </a:p>
           <a:p>
             <a:pPr algn="ctr"/>
             <a:r>
-              <a:rPr sz="1466" b="0">
+              <a:rPr sz="1333" b="0">
                 <a:solidFill>
                   <a:srgbClr val="101010"/>
                 </a:solidFill>
                 <a:latin typeface="Calibri"/>
               </a:rPr>
-              <a:t>Speech support for users who find typing difficult</a:t>
+              <a:t>Evaluate with elderly participants and their caregivers</a:t>
             </a:r>
           </a:p>
         </p:txBody>

</xml_diff>